<commit_message>
fix: correct university/email to Northwestern + fix slide layout overflows
- All files: UIUC/xiyuh5@illinois.edu → Northwestern University/xiyuhuang2026@u.northwestern.edu
- Slide 1: university name updated
- Slide 3: fix results table left position (was Inches(3.75) → Inches(0.3)); table
  was rendering off the right edge of the slide; adjusted column widths to 4.6+0.85+1.05+0.95+2.5
- Slide 8: tighten row gap (2.65→2.52) and box height (2.45→2.35) to clear room
  for bottom note; fix bottom note height (0.35→0.42) and position (7.1→6.97)
  so text no longer clips off slide edge; simplify to single-line note
- Regenerated week7_deliverables.pdf with correct author info

Co-Authored-By: Claude Sonnet 4.6 <noreply@anthropic.com>
</commit_message>
<xml_diff>
--- a/deliverables/week7/final_presentation.pptx
+++ b/deliverables/week7/final_presentation.pptx
@@ -3243,7 +3243,7 @@
                   <a:srgbClr val="FFFFFF"/>
                 </a:solidFill>
               </a:rPr>
-              <a:t>STAT 390 Capstone  •  Sherry Huang  •  UIUC</a:t>
+              <a:t>STAT 390 Capstone  •  Sherry Huang  •  Northwestern University</a:t>
             </a:r>
           </a:p>
         </p:txBody>
@@ -4713,8 +4713,8 @@
         </p:nvSpPr>
         <p:spPr>
           <a:xfrm>
-            <a:off x="3429000" y="3429000"/>
-            <a:ext cx="3931920" cy="502920"/>
+            <a:off x="274320" y="3429000"/>
+            <a:ext cx="4206240" cy="502920"/>
           </a:xfrm>
           <a:prstGeom prst="rect">
             <a:avLst/>
@@ -4756,8 +4756,8 @@
         </p:nvSpPr>
         <p:spPr>
           <a:xfrm>
-            <a:off x="3502152" y="3483864"/>
-            <a:ext cx="3822192" cy="411480"/>
+            <a:off x="347472" y="3483864"/>
+            <a:ext cx="4096512" cy="411480"/>
           </a:xfrm>
           <a:prstGeom prst="rect">
             <a:avLst/>
@@ -4790,8 +4790,8 @@
         </p:nvSpPr>
         <p:spPr>
           <a:xfrm>
-            <a:off x="7360920" y="3429000"/>
-            <a:ext cx="822960" cy="502920"/>
+            <a:off x="4480560" y="3429000"/>
+            <a:ext cx="777240" cy="502920"/>
           </a:xfrm>
           <a:prstGeom prst="rect">
             <a:avLst/>
@@ -4833,8 +4833,8 @@
         </p:nvSpPr>
         <p:spPr>
           <a:xfrm>
-            <a:off x="7434072" y="3483864"/>
-            <a:ext cx="713232" cy="411480"/>
+            <a:off x="4553712" y="3483864"/>
+            <a:ext cx="667512" cy="411480"/>
           </a:xfrm>
           <a:prstGeom prst="rect">
             <a:avLst/>
@@ -4867,8 +4867,8 @@
         </p:nvSpPr>
         <p:spPr>
           <a:xfrm>
-            <a:off x="8183880" y="3429000"/>
-            <a:ext cx="1005840" cy="502920"/>
+            <a:off x="5257800" y="3429000"/>
+            <a:ext cx="960120" cy="502920"/>
           </a:xfrm>
           <a:prstGeom prst="rect">
             <a:avLst/>
@@ -4910,8 +4910,8 @@
         </p:nvSpPr>
         <p:spPr>
           <a:xfrm>
-            <a:off x="8257032" y="3483864"/>
-            <a:ext cx="896112" cy="411480"/>
+            <a:off x="5330952" y="3483864"/>
+            <a:ext cx="850392" cy="411480"/>
           </a:xfrm>
           <a:prstGeom prst="rect">
             <a:avLst/>
@@ -4944,8 +4944,8 @@
         </p:nvSpPr>
         <p:spPr>
           <a:xfrm>
-            <a:off x="9189720" y="3429000"/>
-            <a:ext cx="914400" cy="502920"/>
+            <a:off x="6217920" y="3429000"/>
+            <a:ext cx="868680" cy="502920"/>
           </a:xfrm>
           <a:prstGeom prst="rect">
             <a:avLst/>
@@ -4987,8 +4987,8 @@
         </p:nvSpPr>
         <p:spPr>
           <a:xfrm>
-            <a:off x="9262872" y="3483864"/>
-            <a:ext cx="804672" cy="411480"/>
+            <a:off x="6291072" y="3483864"/>
+            <a:ext cx="758952" cy="411480"/>
           </a:xfrm>
           <a:prstGeom prst="rect">
             <a:avLst/>
@@ -5021,8 +5021,8 @@
         </p:nvSpPr>
         <p:spPr>
           <a:xfrm>
-            <a:off x="10104120" y="3429000"/>
-            <a:ext cx="3657600" cy="502920"/>
+            <a:off x="7086600" y="3429000"/>
+            <a:ext cx="2286000" cy="502920"/>
           </a:xfrm>
           <a:prstGeom prst="rect">
             <a:avLst/>
@@ -5064,8 +5064,8 @@
         </p:nvSpPr>
         <p:spPr>
           <a:xfrm>
-            <a:off x="10177272" y="3483864"/>
-            <a:ext cx="3547872" cy="411480"/>
+            <a:off x="7159752" y="3483864"/>
+            <a:ext cx="2176272" cy="411480"/>
           </a:xfrm>
           <a:prstGeom prst="rect">
             <a:avLst/>
@@ -5098,8 +5098,8 @@
         </p:nvSpPr>
         <p:spPr>
           <a:xfrm>
-            <a:off x="3429000" y="3931920"/>
-            <a:ext cx="3931920" cy="502920"/>
+            <a:off x="274320" y="3931920"/>
+            <a:ext cx="4206240" cy="502920"/>
           </a:xfrm>
           <a:prstGeom prst="rect">
             <a:avLst/>
@@ -5141,8 +5141,8 @@
         </p:nvSpPr>
         <p:spPr>
           <a:xfrm>
-            <a:off x="3502152" y="3986784"/>
-            <a:ext cx="3822192" cy="411480"/>
+            <a:off x="347472" y="3986784"/>
+            <a:ext cx="4096512" cy="411480"/>
           </a:xfrm>
           <a:prstGeom prst="rect">
             <a:avLst/>
@@ -5162,7 +5162,7 @@
                   <a:srgbClr val="444444"/>
                 </a:solidFill>
               </a:rPr>
-              <a:t>exp_001 — Logistic Regression baseline</a:t>
+              <a:t>exp_001  Logistic Regression baseline</a:t>
             </a:r>
           </a:p>
         </p:txBody>
@@ -5175,8 +5175,8 @@
         </p:nvSpPr>
         <p:spPr>
           <a:xfrm>
-            <a:off x="7360920" y="3931920"/>
-            <a:ext cx="822960" cy="502920"/>
+            <a:off x="4480560" y="3931920"/>
+            <a:ext cx="777240" cy="502920"/>
           </a:xfrm>
           <a:prstGeom prst="rect">
             <a:avLst/>
@@ -5218,8 +5218,8 @@
         </p:nvSpPr>
         <p:spPr>
           <a:xfrm>
-            <a:off x="7434072" y="3986784"/>
-            <a:ext cx="713232" cy="411480"/>
+            <a:off x="4553712" y="3986784"/>
+            <a:ext cx="667512" cy="411480"/>
           </a:xfrm>
           <a:prstGeom prst="rect">
             <a:avLst/>
@@ -5252,8 +5252,8 @@
         </p:nvSpPr>
         <p:spPr>
           <a:xfrm>
-            <a:off x="8183880" y="3931920"/>
-            <a:ext cx="1005840" cy="502920"/>
+            <a:off x="5257800" y="3931920"/>
+            <a:ext cx="960120" cy="502920"/>
           </a:xfrm>
           <a:prstGeom prst="rect">
             <a:avLst/>
@@ -5295,8 +5295,8 @@
         </p:nvSpPr>
         <p:spPr>
           <a:xfrm>
-            <a:off x="8257032" y="3986784"/>
-            <a:ext cx="896112" cy="411480"/>
+            <a:off x="5330952" y="3986784"/>
+            <a:ext cx="850392" cy="411480"/>
           </a:xfrm>
           <a:prstGeom prst="rect">
             <a:avLst/>
@@ -5329,8 +5329,8 @@
         </p:nvSpPr>
         <p:spPr>
           <a:xfrm>
-            <a:off x="9189720" y="3931920"/>
-            <a:ext cx="914400" cy="502920"/>
+            <a:off x="6217920" y="3931920"/>
+            <a:ext cx="868680" cy="502920"/>
           </a:xfrm>
           <a:prstGeom prst="rect">
             <a:avLst/>
@@ -5372,8 +5372,8 @@
         </p:nvSpPr>
         <p:spPr>
           <a:xfrm>
-            <a:off x="9262872" y="3986784"/>
-            <a:ext cx="804672" cy="411480"/>
+            <a:off x="6291072" y="3986784"/>
+            <a:ext cx="758952" cy="411480"/>
           </a:xfrm>
           <a:prstGeom prst="rect">
             <a:avLst/>
@@ -5406,8 +5406,8 @@
         </p:nvSpPr>
         <p:spPr>
           <a:xfrm>
-            <a:off x="10104120" y="3931920"/>
-            <a:ext cx="3657600" cy="502920"/>
+            <a:off x="7086600" y="3931920"/>
+            <a:ext cx="2286000" cy="502920"/>
           </a:xfrm>
           <a:prstGeom prst="rect">
             <a:avLst/>
@@ -5449,8 +5449,8 @@
         </p:nvSpPr>
         <p:spPr>
           <a:xfrm>
-            <a:off x="10177272" y="3986784"/>
-            <a:ext cx="3547872" cy="411480"/>
+            <a:off x="7159752" y="3986784"/>
+            <a:ext cx="2176272" cy="411480"/>
           </a:xfrm>
           <a:prstGeom prst="rect">
             <a:avLst/>
@@ -5483,8 +5483,8 @@
         </p:nvSpPr>
         <p:spPr>
           <a:xfrm>
-            <a:off x="3429000" y="4434840"/>
-            <a:ext cx="3931920" cy="502920"/>
+            <a:off x="274320" y="4434840"/>
+            <a:ext cx="4206240" cy="502920"/>
           </a:xfrm>
           <a:prstGeom prst="rect">
             <a:avLst/>
@@ -5526,8 +5526,8 @@
         </p:nvSpPr>
         <p:spPr>
           <a:xfrm>
-            <a:off x="3502152" y="4489704"/>
-            <a:ext cx="3822192" cy="411480"/>
+            <a:off x="347472" y="4489704"/>
+            <a:ext cx="4096512" cy="411480"/>
           </a:xfrm>
           <a:prstGeom prst="rect">
             <a:avLst/>
@@ -5547,7 +5547,7 @@
                   <a:srgbClr val="444444"/>
                 </a:solidFill>
               </a:rPr>
-              <a:t>exp_030 — Final LightGBM (validation)</a:t>
+              <a:t>exp_030  Final LightGBM (validation)</a:t>
             </a:r>
           </a:p>
         </p:txBody>
@@ -5560,8 +5560,8 @@
         </p:nvSpPr>
         <p:spPr>
           <a:xfrm>
-            <a:off x="7360920" y="4434840"/>
-            <a:ext cx="822960" cy="502920"/>
+            <a:off x="4480560" y="4434840"/>
+            <a:ext cx="777240" cy="502920"/>
           </a:xfrm>
           <a:prstGeom prst="rect">
             <a:avLst/>
@@ -5603,8 +5603,8 @@
         </p:nvSpPr>
         <p:spPr>
           <a:xfrm>
-            <a:off x="7434072" y="4489704"/>
-            <a:ext cx="713232" cy="411480"/>
+            <a:off x="4553712" y="4489704"/>
+            <a:ext cx="667512" cy="411480"/>
           </a:xfrm>
           <a:prstGeom prst="rect">
             <a:avLst/>
@@ -5637,8 +5637,8 @@
         </p:nvSpPr>
         <p:spPr>
           <a:xfrm>
-            <a:off x="8183880" y="4434840"/>
-            <a:ext cx="1005840" cy="502920"/>
+            <a:off x="5257800" y="4434840"/>
+            <a:ext cx="960120" cy="502920"/>
           </a:xfrm>
           <a:prstGeom prst="rect">
             <a:avLst/>
@@ -5680,8 +5680,8 @@
         </p:nvSpPr>
         <p:spPr>
           <a:xfrm>
-            <a:off x="8257032" y="4489704"/>
-            <a:ext cx="896112" cy="411480"/>
+            <a:off x="5330952" y="4489704"/>
+            <a:ext cx="850392" cy="411480"/>
           </a:xfrm>
           <a:prstGeom prst="rect">
             <a:avLst/>
@@ -5714,8 +5714,8 @@
         </p:nvSpPr>
         <p:spPr>
           <a:xfrm>
-            <a:off x="9189720" y="4434840"/>
-            <a:ext cx="914400" cy="502920"/>
+            <a:off x="6217920" y="4434840"/>
+            <a:ext cx="868680" cy="502920"/>
           </a:xfrm>
           <a:prstGeom prst="rect">
             <a:avLst/>
@@ -5757,8 +5757,8 @@
         </p:nvSpPr>
         <p:spPr>
           <a:xfrm>
-            <a:off x="9262872" y="4489704"/>
-            <a:ext cx="804672" cy="411480"/>
+            <a:off x="6291072" y="4489704"/>
+            <a:ext cx="758952" cy="411480"/>
           </a:xfrm>
           <a:prstGeom prst="rect">
             <a:avLst/>
@@ -5791,8 +5791,8 @@
         </p:nvSpPr>
         <p:spPr>
           <a:xfrm>
-            <a:off x="10104120" y="4434840"/>
-            <a:ext cx="3657600" cy="502920"/>
+            <a:off x="7086600" y="4434840"/>
+            <a:ext cx="2286000" cy="502920"/>
           </a:xfrm>
           <a:prstGeom prst="rect">
             <a:avLst/>
@@ -5834,8 +5834,8 @@
         </p:nvSpPr>
         <p:spPr>
           <a:xfrm>
-            <a:off x="10177272" y="4489704"/>
-            <a:ext cx="3547872" cy="411480"/>
+            <a:off x="7159752" y="4489704"/>
+            <a:ext cx="2176272" cy="411480"/>
           </a:xfrm>
           <a:prstGeom prst="rect">
             <a:avLst/>
@@ -5855,7 +5855,7 @@
                   <a:srgbClr val="444444"/>
                 </a:solidFill>
               </a:rPr>
-              <a:t>+21.6% F1</a:t>
+              <a:t>+21.6% F1 gain</a:t>
             </a:r>
           </a:p>
         </p:txBody>
@@ -5868,8 +5868,8 @@
         </p:nvSpPr>
         <p:spPr>
           <a:xfrm>
-            <a:off x="3429000" y="4937760"/>
-            <a:ext cx="3931920" cy="502920"/>
+            <a:off x="274320" y="4937760"/>
+            <a:ext cx="4206240" cy="502920"/>
           </a:xfrm>
           <a:prstGeom prst="rect">
             <a:avLst/>
@@ -5911,8 +5911,8 @@
         </p:nvSpPr>
         <p:spPr>
           <a:xfrm>
-            <a:off x="3502152" y="4992624"/>
-            <a:ext cx="3822192" cy="411480"/>
+            <a:off x="347472" y="4992624"/>
+            <a:ext cx="4096512" cy="411480"/>
           </a:xfrm>
           <a:prstGeom prst="rect">
             <a:avLst/>
@@ -5932,7 +5932,7 @@
                   <a:srgbClr val="444444"/>
                 </a:solidFill>
               </a:rPr>
-              <a:t>exp_030 — Final LightGBM (TEST SET)</a:t>
+              <a:t>exp_030  Final LightGBM (TEST SET)</a:t>
             </a:r>
           </a:p>
         </p:txBody>
@@ -5945,8 +5945,8 @@
         </p:nvSpPr>
         <p:spPr>
           <a:xfrm>
-            <a:off x="7360920" y="4937760"/>
-            <a:ext cx="822960" cy="502920"/>
+            <a:off x="4480560" y="4937760"/>
+            <a:ext cx="777240" cy="502920"/>
           </a:xfrm>
           <a:prstGeom prst="rect">
             <a:avLst/>
@@ -5988,8 +5988,8 @@
         </p:nvSpPr>
         <p:spPr>
           <a:xfrm>
-            <a:off x="7434072" y="4992624"/>
-            <a:ext cx="713232" cy="411480"/>
+            <a:off x="4553712" y="4992624"/>
+            <a:ext cx="667512" cy="411480"/>
           </a:xfrm>
           <a:prstGeom prst="rect">
             <a:avLst/>
@@ -6022,8 +6022,8 @@
         </p:nvSpPr>
         <p:spPr>
           <a:xfrm>
-            <a:off x="8183880" y="4937760"/>
-            <a:ext cx="1005840" cy="502920"/>
+            <a:off x="5257800" y="4937760"/>
+            <a:ext cx="960120" cy="502920"/>
           </a:xfrm>
           <a:prstGeom prst="rect">
             <a:avLst/>
@@ -6065,8 +6065,8 @@
         </p:nvSpPr>
         <p:spPr>
           <a:xfrm>
-            <a:off x="8257032" y="4992624"/>
-            <a:ext cx="896112" cy="411480"/>
+            <a:off x="5330952" y="4992624"/>
+            <a:ext cx="850392" cy="411480"/>
           </a:xfrm>
           <a:prstGeom prst="rect">
             <a:avLst/>
@@ -6099,8 +6099,8 @@
         </p:nvSpPr>
         <p:spPr>
           <a:xfrm>
-            <a:off x="9189720" y="4937760"/>
-            <a:ext cx="914400" cy="502920"/>
+            <a:off x="6217920" y="4937760"/>
+            <a:ext cx="868680" cy="502920"/>
           </a:xfrm>
           <a:prstGeom prst="rect">
             <a:avLst/>
@@ -6142,8 +6142,8 @@
         </p:nvSpPr>
         <p:spPr>
           <a:xfrm>
-            <a:off x="9262872" y="4992624"/>
-            <a:ext cx="804672" cy="411480"/>
+            <a:off x="6291072" y="4992624"/>
+            <a:ext cx="758952" cy="411480"/>
           </a:xfrm>
           <a:prstGeom prst="rect">
             <a:avLst/>
@@ -6176,8 +6176,8 @@
         </p:nvSpPr>
         <p:spPr>
           <a:xfrm>
-            <a:off x="10104120" y="4937760"/>
-            <a:ext cx="3657600" cy="502920"/>
+            <a:off x="7086600" y="4937760"/>
+            <a:ext cx="2286000" cy="502920"/>
           </a:xfrm>
           <a:prstGeom prst="rect">
             <a:avLst/>
@@ -6219,8 +6219,8 @@
         </p:nvSpPr>
         <p:spPr>
           <a:xfrm>
-            <a:off x="10177272" y="4992624"/>
-            <a:ext cx="3547872" cy="411480"/>
+            <a:off x="7159752" y="4992624"/>
+            <a:ext cx="2176272" cy="411480"/>
           </a:xfrm>
           <a:prstGeom prst="rect">
             <a:avLst/>
@@ -6240,7 +6240,7 @@
                   <a:srgbClr val="444444"/>
                 </a:solidFill>
               </a:rPr>
-              <a:t>Held-out, opened once</a:t>
+              <a:t>Held-out, once</a:t>
             </a:r>
           </a:p>
         </p:txBody>
@@ -14357,7 +14357,7 @@
         <p:spPr>
           <a:xfrm>
             <a:off x="274320" y="1737360"/>
-            <a:ext cx="5669280" cy="2240280"/>
+            <a:ext cx="5669280" cy="2148840"/>
           </a:xfrm>
           <a:prstGeom prst="rect">
             <a:avLst/>
@@ -14400,7 +14400,7 @@
         <p:spPr>
           <a:xfrm>
             <a:off x="411480" y="1828800"/>
-            <a:ext cx="5394960" cy="365760"/>
+            <a:ext cx="5394960" cy="347472"/>
           </a:xfrm>
           <a:prstGeom prst="rect">
             <a:avLst/>
@@ -14434,7 +14434,7 @@
         <p:spPr>
           <a:xfrm>
             <a:off x="411480" y="2194560"/>
-            <a:ext cx="5394960" cy="1691640"/>
+            <a:ext cx="5394960" cy="1600200"/>
           </a:xfrm>
           <a:prstGeom prst="rect">
             <a:avLst/>
@@ -14517,7 +14517,7 @@
         <p:spPr>
           <a:xfrm>
             <a:off x="6217920" y="1737360"/>
-            <a:ext cx="5669280" cy="2240280"/>
+            <a:ext cx="5669280" cy="2148840"/>
           </a:xfrm>
           <a:prstGeom prst="rect">
             <a:avLst/>
@@ -14560,7 +14560,7 @@
         <p:spPr>
           <a:xfrm>
             <a:off x="6355080" y="1828800"/>
-            <a:ext cx="5394960" cy="365760"/>
+            <a:ext cx="5394960" cy="347472"/>
           </a:xfrm>
           <a:prstGeom prst="rect">
             <a:avLst/>
@@ -14594,7 +14594,7 @@
         <p:spPr>
           <a:xfrm>
             <a:off x="6355080" y="2194560"/>
-            <a:ext cx="5394960" cy="1691640"/>
+            <a:ext cx="5394960" cy="1600200"/>
           </a:xfrm>
           <a:prstGeom prst="rect">
             <a:avLst/>
@@ -14676,8 +14676,8 @@
         </p:nvSpPr>
         <p:spPr>
           <a:xfrm>
-            <a:off x="274320" y="4160520"/>
-            <a:ext cx="5669280" cy="2240280"/>
+            <a:off x="274320" y="4041648"/>
+            <a:ext cx="5669280" cy="2148840"/>
           </a:xfrm>
           <a:prstGeom prst="rect">
             <a:avLst/>
@@ -14719,8 +14719,8 @@
         </p:nvSpPr>
         <p:spPr>
           <a:xfrm>
-            <a:off x="411480" y="4251960"/>
-            <a:ext cx="5394960" cy="365760"/>
+            <a:off x="411480" y="4133088"/>
+            <a:ext cx="5394960" cy="347472"/>
           </a:xfrm>
           <a:prstGeom prst="rect">
             <a:avLst/>
@@ -14753,8 +14753,8 @@
         </p:nvSpPr>
         <p:spPr>
           <a:xfrm>
-            <a:off x="411480" y="4617720"/>
-            <a:ext cx="5394960" cy="1691640"/>
+            <a:off x="411480" y="4498848"/>
+            <a:ext cx="5394960" cy="1600200"/>
           </a:xfrm>
           <a:prstGeom prst="rect">
             <a:avLst/>
@@ -14836,8 +14836,8 @@
         </p:nvSpPr>
         <p:spPr>
           <a:xfrm>
-            <a:off x="6217920" y="4160520"/>
-            <a:ext cx="5669280" cy="2240280"/>
+            <a:off x="6217920" y="4041648"/>
+            <a:ext cx="5669280" cy="2148840"/>
           </a:xfrm>
           <a:prstGeom prst="rect">
             <a:avLst/>
@@ -14879,8 +14879,8 @@
         </p:nvSpPr>
         <p:spPr>
           <a:xfrm>
-            <a:off x="6355080" y="4251960"/>
-            <a:ext cx="5394960" cy="365760"/>
+            <a:off x="6355080" y="4133088"/>
+            <a:ext cx="5394960" cy="347472"/>
           </a:xfrm>
           <a:prstGeom prst="rect">
             <a:avLst/>
@@ -14913,8 +14913,8 @@
         </p:nvSpPr>
         <p:spPr>
           <a:xfrm>
-            <a:off x="6355080" y="4617720"/>
-            <a:ext cx="5394960" cy="1691640"/>
+            <a:off x="6355080" y="4498848"/>
+            <a:ext cx="5394960" cy="1600200"/>
           </a:xfrm>
           <a:prstGeom prst="rect">
             <a:avLst/>
@@ -14996,8 +14996,8 @@
         </p:nvSpPr>
         <p:spPr>
           <a:xfrm>
-            <a:off x="457200" y="6492240"/>
-            <a:ext cx="11247120" cy="320040"/>
+            <a:off x="457200" y="6373368"/>
+            <a:ext cx="11247120" cy="384048"/>
           </a:xfrm>
           <a:prstGeom prst="rect">
             <a:avLst/>
@@ -15017,8 +15017,7 @@
                   <a:srgbClr val="D0E4F5"/>
                 </a:solidFill>
               </a:rPr>
-              <a:t>The loop shifts the bottleneck from execution to diagnosis.
-The most valuable contribution was asking the right question — not running the experiments.</a:t>
+              <a:t>Key insight: the loop shifts the bottleneck from execution to diagnosis — asking the right question matters more than running more experiments.</a:t>
             </a:r>
           </a:p>
         </p:txBody>

</xml_diff>

<commit_message>
fix: correct bullet spacing bug — gap was multiplied by 72 (inches), now in points
p.space_before = Pt(gap * 72) with gap=2 = 144pt = 2-inch gaps between bullets.
Fixed: p.space_before = Pt(gap) with default gap=4pt. Affects slides 5, 6, 7, 8.
Also confirms slide 3 table l=0.3 (not 3.75) so table no longer overflows right edge.

Co-Authored-By: Claude Sonnet 4.6 <noreply@anthropic.com>
</commit_message>
<xml_diff>
--- a/deliverables/week7/final_presentation.pptx
+++ b/deliverables/week7/final_presentation.pptx
@@ -3656,7 +3656,7 @@
           <a:p>
             <a:pPr>
               <a:spcBef>
-                <a:spcPts val="360"/>
+                <a:spcPts val="400"/>
               </a:spcBef>
             </a:pPr>
             <a:r>
@@ -3671,7 +3671,7 @@
           <a:p>
             <a:pPr>
               <a:spcBef>
-                <a:spcPts val="360"/>
+                <a:spcPts val="400"/>
               </a:spcBef>
             </a:pPr>
             <a:r>
@@ -3686,7 +3686,7 @@
           <a:p>
             <a:pPr>
               <a:spcBef>
-                <a:spcPts val="360"/>
+                <a:spcPts val="400"/>
               </a:spcBef>
             </a:pPr>
             <a:r>
@@ -3701,7 +3701,7 @@
           <a:p>
             <a:pPr>
               <a:spcBef>
-                <a:spcPts val="360"/>
+                <a:spcPts val="400"/>
               </a:spcBef>
             </a:pPr>
             <a:r>
@@ -3716,7 +3716,7 @@
           <a:p>
             <a:pPr>
               <a:spcBef>
-                <a:spcPts val="360"/>
+                <a:spcPts val="400"/>
               </a:spcBef>
             </a:pPr>
             <a:r>
@@ -3831,7 +3831,7 @@
           <a:p>
             <a:pPr>
               <a:spcBef>
-                <a:spcPts val="360"/>
+                <a:spcPts val="400"/>
               </a:spcBef>
             </a:pPr>
             <a:r>
@@ -3846,7 +3846,7 @@
           <a:p>
             <a:pPr>
               <a:spcBef>
-                <a:spcPts val="360"/>
+                <a:spcPts val="400"/>
               </a:spcBef>
             </a:pPr>
             <a:r>
@@ -3861,7 +3861,7 @@
           <a:p>
             <a:pPr>
               <a:spcBef>
-                <a:spcPts val="360"/>
+                <a:spcPts val="400"/>
               </a:spcBef>
             </a:pPr>
             <a:r>
@@ -3876,7 +3876,7 @@
           <a:p>
             <a:pPr>
               <a:spcBef>
-                <a:spcPts val="360"/>
+                <a:spcPts val="400"/>
               </a:spcBef>
             </a:pPr>
             <a:r>
@@ -3891,7 +3891,7 @@
           <a:p>
             <a:pPr>
               <a:spcBef>
-                <a:spcPts val="360"/>
+                <a:spcPts val="400"/>
               </a:spcBef>
             </a:pPr>
             <a:r>
@@ -3906,7 +3906,7 @@
           <a:p>
             <a:pPr>
               <a:spcBef>
-                <a:spcPts val="360"/>
+                <a:spcPts val="400"/>
               </a:spcBef>
             </a:pPr>
             <a:r>
@@ -10055,7 +10055,7 @@
           <a:p>
             <a:pPr>
               <a:spcBef>
-                <a:spcPts val="14400"/>
+                <a:spcPts val="400"/>
               </a:spcBef>
             </a:pPr>
             <a:r>
@@ -10070,7 +10070,7 @@
           <a:p>
             <a:pPr>
               <a:spcBef>
-                <a:spcPts val="14400"/>
+                <a:spcPts val="400"/>
               </a:spcBef>
             </a:pPr>
             <a:r>
@@ -10085,7 +10085,7 @@
           <a:p>
             <a:pPr>
               <a:spcBef>
-                <a:spcPts val="14400"/>
+                <a:spcPts val="400"/>
               </a:spcBef>
             </a:pPr>
             <a:r>
@@ -10100,7 +10100,7 @@
           <a:p>
             <a:pPr>
               <a:spcBef>
-                <a:spcPts val="14400"/>
+                <a:spcPts val="400"/>
               </a:spcBef>
             </a:pPr>
             <a:r>
@@ -10115,7 +10115,7 @@
           <a:p>
             <a:pPr>
               <a:spcBef>
-                <a:spcPts val="14400"/>
+                <a:spcPts val="400"/>
               </a:spcBef>
             </a:pPr>
             <a:r>
@@ -10130,7 +10130,7 @@
           <a:p>
             <a:pPr>
               <a:spcBef>
-                <a:spcPts val="14400"/>
+                <a:spcPts val="400"/>
               </a:spcBef>
             </a:pPr>
             <a:r>
@@ -10145,7 +10145,7 @@
           <a:p>
             <a:pPr>
               <a:spcBef>
-                <a:spcPts val="14400"/>
+                <a:spcPts val="400"/>
               </a:spcBef>
             </a:pPr>
             <a:r>
@@ -10260,7 +10260,7 @@
           <a:p>
             <a:pPr>
               <a:spcBef>
-                <a:spcPts val="14400"/>
+                <a:spcPts val="400"/>
               </a:spcBef>
             </a:pPr>
             <a:r>
@@ -10275,7 +10275,7 @@
           <a:p>
             <a:pPr>
               <a:spcBef>
-                <a:spcPts val="14400"/>
+                <a:spcPts val="400"/>
               </a:spcBef>
             </a:pPr>
             <a:r>
@@ -10290,7 +10290,7 @@
           <a:p>
             <a:pPr>
               <a:spcBef>
-                <a:spcPts val="14400"/>
+                <a:spcPts val="400"/>
               </a:spcBef>
             </a:pPr>
             <a:r>
@@ -10305,7 +10305,7 @@
           <a:p>
             <a:pPr>
               <a:spcBef>
-                <a:spcPts val="14400"/>
+                <a:spcPts val="400"/>
               </a:spcBef>
             </a:pPr>
             <a:r>
@@ -10320,7 +10320,7 @@
           <a:p>
             <a:pPr>
               <a:spcBef>
-                <a:spcPts val="14400"/>
+                <a:spcPts val="400"/>
               </a:spcBef>
             </a:pPr>
             <a:r>
@@ -10335,7 +10335,7 @@
           <a:p>
             <a:pPr>
               <a:spcBef>
-                <a:spcPts val="14400"/>
+                <a:spcPts val="400"/>
               </a:spcBef>
             </a:pPr>
             <a:r>
@@ -10350,7 +10350,7 @@
           <a:p>
             <a:pPr>
               <a:spcBef>
-                <a:spcPts val="14400"/>
+                <a:spcPts val="400"/>
               </a:spcBef>
             </a:pPr>
             <a:r>
@@ -10365,7 +10365,7 @@
           <a:p>
             <a:pPr>
               <a:spcBef>
-                <a:spcPts val="14400"/>
+                <a:spcPts val="400"/>
               </a:spcBef>
             </a:pPr>
             <a:r>
@@ -11231,7 +11231,7 @@
           <a:p>
             <a:pPr>
               <a:spcBef>
-                <a:spcPts val="7200"/>
+                <a:spcPts val="400"/>
               </a:spcBef>
             </a:pPr>
             <a:r>
@@ -11246,7 +11246,7 @@
           <a:p>
             <a:pPr>
               <a:spcBef>
-                <a:spcPts val="7200"/>
+                <a:spcPts val="400"/>
               </a:spcBef>
             </a:pPr>
             <a:r>
@@ -11261,7 +11261,7 @@
           <a:p>
             <a:pPr>
               <a:spcBef>
-                <a:spcPts val="7200"/>
+                <a:spcPts val="400"/>
               </a:spcBef>
             </a:pPr>
             <a:r>
@@ -11276,7 +11276,7 @@
           <a:p>
             <a:pPr>
               <a:spcBef>
-                <a:spcPts val="7200"/>
+                <a:spcPts val="400"/>
               </a:spcBef>
             </a:pPr>
             <a:r>
@@ -11291,7 +11291,7 @@
           <a:p>
             <a:pPr>
               <a:spcBef>
-                <a:spcPts val="7200"/>
+                <a:spcPts val="400"/>
               </a:spcBef>
             </a:pPr>
             <a:r>
@@ -13802,7 +13802,7 @@
           <a:p>
             <a:pPr>
               <a:spcBef>
-                <a:spcPts val="21600"/>
+                <a:spcPts val="400"/>
               </a:spcBef>
             </a:pPr>
             <a:r>
@@ -13825,7 +13825,7 @@
           <a:p>
             <a:pPr>
               <a:spcBef>
-                <a:spcPts val="21600"/>
+                <a:spcPts val="400"/>
               </a:spcBef>
             </a:pPr>
             <a:r>
@@ -13848,7 +13848,7 @@
           <a:p>
             <a:pPr>
               <a:spcBef>
-                <a:spcPts val="21600"/>
+                <a:spcPts val="400"/>
               </a:spcBef>
             </a:pPr>
             <a:r>
@@ -13871,7 +13871,7 @@
           <a:p>
             <a:pPr>
               <a:spcBef>
-                <a:spcPts val="21600"/>
+                <a:spcPts val="400"/>
               </a:spcBef>
             </a:pPr>
             <a:r>
@@ -13894,7 +13894,7 @@
           <a:p>
             <a:pPr>
               <a:spcBef>
-                <a:spcPts val="21600"/>
+                <a:spcPts val="400"/>
               </a:spcBef>
             </a:pPr>
             <a:r>
@@ -13917,7 +13917,7 @@
           <a:p>
             <a:pPr>
               <a:spcBef>
-                <a:spcPts val="21600"/>
+                <a:spcPts val="400"/>
               </a:spcBef>
             </a:pPr>
             <a:r>
@@ -14040,7 +14040,7 @@
           <a:p>
             <a:pPr>
               <a:spcBef>
-                <a:spcPts val="21600"/>
+                <a:spcPts val="400"/>
               </a:spcBef>
             </a:pPr>
             <a:r>
@@ -14063,7 +14063,7 @@
           <a:p>
             <a:pPr>
               <a:spcBef>
-                <a:spcPts val="21600"/>
+                <a:spcPts val="400"/>
               </a:spcBef>
             </a:pPr>
             <a:r>
@@ -14086,7 +14086,7 @@
           <a:p>
             <a:pPr>
               <a:spcBef>
-                <a:spcPts val="21600"/>
+                <a:spcPts val="400"/>
               </a:spcBef>
             </a:pPr>
             <a:r>
@@ -14109,7 +14109,7 @@
           <a:p>
             <a:pPr>
               <a:spcBef>
-                <a:spcPts val="21600"/>
+                <a:spcPts val="400"/>
               </a:spcBef>
             </a:pPr>
             <a:r>
@@ -14132,7 +14132,7 @@
           <a:p>
             <a:pPr>
               <a:spcBef>
-                <a:spcPts val="21600"/>
+                <a:spcPts val="400"/>
               </a:spcBef>
             </a:pPr>
             <a:r>
@@ -14155,7 +14155,7 @@
           <a:p>
             <a:pPr>
               <a:spcBef>
-                <a:spcPts val="21600"/>
+                <a:spcPts val="400"/>
               </a:spcBef>
             </a:pPr>
             <a:r>
@@ -14449,7 +14449,7 @@
           <a:p>
             <a:pPr>
               <a:spcBef>
-                <a:spcPts val="7200"/>
+                <a:spcPts val="400"/>
               </a:spcBef>
             </a:pPr>
             <a:r>
@@ -14464,7 +14464,7 @@
           <a:p>
             <a:pPr>
               <a:spcBef>
-                <a:spcPts val="7200"/>
+                <a:spcPts val="400"/>
               </a:spcBef>
             </a:pPr>
             <a:r>
@@ -14479,7 +14479,7 @@
           <a:p>
             <a:pPr>
               <a:spcBef>
-                <a:spcPts val="7200"/>
+                <a:spcPts val="400"/>
               </a:spcBef>
             </a:pPr>
             <a:r>
@@ -14494,7 +14494,7 @@
           <a:p>
             <a:pPr>
               <a:spcBef>
-                <a:spcPts val="7200"/>
+                <a:spcPts val="400"/>
               </a:spcBef>
             </a:pPr>
             <a:r>
@@ -14609,7 +14609,7 @@
           <a:p>
             <a:pPr>
               <a:spcBef>
-                <a:spcPts val="7200"/>
+                <a:spcPts val="400"/>
               </a:spcBef>
             </a:pPr>
             <a:r>
@@ -14624,7 +14624,7 @@
           <a:p>
             <a:pPr>
               <a:spcBef>
-                <a:spcPts val="7200"/>
+                <a:spcPts val="400"/>
               </a:spcBef>
             </a:pPr>
             <a:r>
@@ -14639,7 +14639,7 @@
           <a:p>
             <a:pPr>
               <a:spcBef>
-                <a:spcPts val="7200"/>
+                <a:spcPts val="400"/>
               </a:spcBef>
             </a:pPr>
             <a:r>
@@ -14654,7 +14654,7 @@
           <a:p>
             <a:pPr>
               <a:spcBef>
-                <a:spcPts val="7200"/>
+                <a:spcPts val="400"/>
               </a:spcBef>
             </a:pPr>
             <a:r>
@@ -14769,7 +14769,7 @@
           <a:p>
             <a:pPr>
               <a:spcBef>
-                <a:spcPts val="7200"/>
+                <a:spcPts val="400"/>
               </a:spcBef>
             </a:pPr>
             <a:r>
@@ -14784,7 +14784,7 @@
           <a:p>
             <a:pPr>
               <a:spcBef>
-                <a:spcPts val="7200"/>
+                <a:spcPts val="400"/>
               </a:spcBef>
             </a:pPr>
             <a:r>
@@ -14799,7 +14799,7 @@
           <a:p>
             <a:pPr>
               <a:spcBef>
-                <a:spcPts val="7200"/>
+                <a:spcPts val="400"/>
               </a:spcBef>
             </a:pPr>
             <a:r>
@@ -14814,7 +14814,7 @@
           <a:p>
             <a:pPr>
               <a:spcBef>
-                <a:spcPts val="7200"/>
+                <a:spcPts val="400"/>
               </a:spcBef>
             </a:pPr>
             <a:r>
@@ -14929,7 +14929,7 @@
           <a:p>
             <a:pPr>
               <a:spcBef>
-                <a:spcPts val="7200"/>
+                <a:spcPts val="400"/>
               </a:spcBef>
             </a:pPr>
             <a:r>
@@ -14944,7 +14944,7 @@
           <a:p>
             <a:pPr>
               <a:spcBef>
-                <a:spcPts val="7200"/>
+                <a:spcPts val="400"/>
               </a:spcBef>
             </a:pPr>
             <a:r>
@@ -14959,7 +14959,7 @@
           <a:p>
             <a:pPr>
               <a:spcBef>
-                <a:spcPts val="7200"/>
+                <a:spcPts val="400"/>
               </a:spcBef>
             </a:pPr>
             <a:r>
@@ -14974,7 +14974,7 @@
           <a:p>
             <a:pPr>
               <a:spcBef>
-                <a:spcPts val="7200"/>
+                <a:spcPts val="400"/>
               </a:spcBef>
             </a:pPr>
             <a:r>

</xml_diff>